<commit_message>
example 1 looks good
</commit_message>
<xml_diff>
--- a/docs/example1_walkthrough.pptx
+++ b/docs/example1_walkthrough.pptx
@@ -3243,7 +3243,43 @@
                 </a:solidFill>
                 <a:latin typeface="Aptos"/>
               </a:rPr>
-              <a:t>In our library for sets of integers, we require that all integers have certain functions like </a:t>
+              <a:t>We store sets of integers, </a:t>
+            </a:r>
+            <a:r>
+              <a:rPr sz="1600">
+                <a:solidFill>
+                  <a:srgbClr val="FFFFFF"/>
+                </a:solidFill>
+                <a:latin typeface="Consolas"/>
+              </a:rPr>
+              <a:t>u8</a:t>
+            </a:r>
+            <a:r>
+              <a:rPr sz="1600">
+                <a:solidFill>
+                  <a:srgbClr val="E6E6E6"/>
+                </a:solidFill>
+                <a:latin typeface="Aptos"/>
+              </a:rPr>
+              <a:t>, </a:t>
+            </a:r>
+            <a:r>
+              <a:rPr sz="1600">
+                <a:solidFill>
+                  <a:srgbClr val="FFFFFF"/>
+                </a:solidFill>
+                <a:latin typeface="Consolas"/>
+              </a:rPr>
+              <a:t>i16</a:t>
+            </a:r>
+            <a:r>
+              <a:rPr sz="1600">
+                <a:solidFill>
+                  <a:srgbClr val="E6E6E6"/>
+                </a:solidFill>
+                <a:latin typeface="Aptos"/>
+              </a:rPr>
+              <a:t>, etc.. Every integer type must have functions like </a:t>
             </a:r>
             <a:r>
               <a:rPr sz="1600">
@@ -3550,7 +3586,7 @@
                 </a:solidFill>
                 <a:latin typeface="Consolas"/>
               </a:rPr>
-              <a:t>// Mini version of `range-set-blaze`'s Integer pattern.</a:t>
+              <a:t>// Mini `range-set-blaze` Integer</a:t>
             </a:r>
           </a:p>
           <a:p>
@@ -3935,11 +3971,11 @@
             <a:r>
               <a:rPr sz="1600">
                 <a:solidFill>
-                  <a:srgbClr val="CE9178"/>
-                </a:solidFill>
-                <a:latin typeface="Consolas"/>
-              </a:rPr>
-              <a:t>/// Returns an exhausted range, which is a range that starts from the maximum value and ends at the minimum value.</a:t>
+                  <a:srgbClr val="6A9955"/>
+                </a:solidFill>
+                <a:latin typeface="Consolas"/>
+              </a:rPr>
+              <a:t>// Default behavior inherited by implementors.</a:t>
             </a:r>
           </a:p>
           <a:p>
@@ -3966,11 +4002,11 @@
             <a:r>
               <a:rPr sz="1600">
                 <a:solidFill>
-                  <a:srgbClr val="CE9178"/>
-                </a:solidFill>
-                <a:latin typeface="Consolas"/>
-              </a:rPr>
-              <a:t>/// This results in an empty range.</a:t>
+                  <a:srgbClr val="6A9955"/>
+                </a:solidFill>
+                <a:latin typeface="Consolas"/>
+              </a:rPr>
+              <a:t>// Any impl can override this method.</a:t>
             </a:r>
           </a:p>
           <a:p>
@@ -3985,24 +4021,6 @@
                 <a:spcPts val="0"/>
               </a:spcAft>
             </a:pPr>
-            <a:r>
-              <a:rPr sz="1600">
-                <a:solidFill>
-                  <a:srgbClr val="DCDCDC"/>
-                </a:solidFill>
-                <a:latin typeface="Consolas"/>
-              </a:rPr>
-              <a:t>    </a:t>
-            </a:r>
-            <a:r>
-              <a:rPr sz="1600">
-                <a:solidFill>
-                  <a:srgbClr val="6A9955"/>
-                </a:solidFill>
-                <a:latin typeface="Consolas"/>
-              </a:rPr>
-              <a:t>//</a:t>
-            </a:r>
           </a:p>
           <a:p>
             <a:pPr>
@@ -4028,11 +4046,11 @@
             <a:r>
               <a:rPr sz="1600">
                 <a:solidFill>
-                  <a:srgbClr val="6A9955"/>
-                </a:solidFill>
-                <a:latin typeface="Consolas"/>
-              </a:rPr>
-              <a:t>// Default behavior inherited by implementors.</a:t>
+                  <a:srgbClr val="CE9178"/>
+                </a:solidFill>
+                <a:latin typeface="Consolas"/>
+              </a:rPr>
+              <a:t>/// Returns an exhausted (empty) range`.</a:t>
             </a:r>
           </a:p>
           <a:p>
@@ -4059,11 +4077,128 @@
             <a:r>
               <a:rPr sz="1600">
                 <a:solidFill>
-                  <a:srgbClr val="6A9955"/>
-                </a:solidFill>
-                <a:latin typeface="Consolas"/>
-              </a:rPr>
-              <a:t>// Any impl can override this method if it needs specialized behavior.</a:t>
+                  <a:srgbClr val="C586C0"/>
+                </a:solidFill>
+                <a:latin typeface="Consolas"/>
+              </a:rPr>
+              <a:t>fn</a:t>
+            </a:r>
+            <a:r>
+              <a:rPr sz="1600">
+                <a:solidFill>
+                  <a:srgbClr val="DCDCDC"/>
+                </a:solidFill>
+                <a:latin typeface="Consolas"/>
+              </a:rPr>
+              <a:t> </a:t>
+            </a:r>
+            <a:r>
+              <a:rPr sz="1600">
+                <a:solidFill>
+                  <a:srgbClr val="DCDCAA"/>
+                </a:solidFill>
+                <a:latin typeface="Consolas"/>
+              </a:rPr>
+              <a:t>exhausted_range</a:t>
+            </a:r>
+            <a:r>
+              <a:rPr sz="1600">
+                <a:solidFill>
+                  <a:srgbClr val="DCDCDC"/>
+                </a:solidFill>
+                <a:latin typeface="Consolas"/>
+              </a:rPr>
+              <a:t>(</a:t>
+            </a:r>
+            <a:r>
+              <a:rPr sz="1600">
+                <a:solidFill>
+                  <a:srgbClr val="DCDCDC"/>
+                </a:solidFill>
+                <a:latin typeface="Consolas"/>
+              </a:rPr>
+              <a:t>)</a:t>
+            </a:r>
+            <a:r>
+              <a:rPr sz="1600">
+                <a:solidFill>
+                  <a:srgbClr val="DCDCDC"/>
+                </a:solidFill>
+                <a:latin typeface="Consolas"/>
+              </a:rPr>
+              <a:t> </a:t>
+            </a:r>
+            <a:r>
+              <a:rPr sz="1600">
+                <a:solidFill>
+                  <a:srgbClr val="DCDCDC"/>
+                </a:solidFill>
+                <a:latin typeface="Consolas"/>
+              </a:rPr>
+              <a:t>-&gt;</a:t>
+            </a:r>
+            <a:r>
+              <a:rPr sz="1600">
+                <a:solidFill>
+                  <a:srgbClr val="DCDCDC"/>
+                </a:solidFill>
+                <a:latin typeface="Consolas"/>
+              </a:rPr>
+              <a:t> </a:t>
+            </a:r>
+            <a:r>
+              <a:rPr sz="1600">
+                <a:solidFill>
+                  <a:srgbClr val="4EC9B0"/>
+                </a:solidFill>
+                <a:latin typeface="Consolas"/>
+              </a:rPr>
+              <a:t>RangeInclusive</a:t>
+            </a:r>
+            <a:r>
+              <a:rPr sz="1600">
+                <a:solidFill>
+                  <a:srgbClr val="DCDCDC"/>
+                </a:solidFill>
+                <a:latin typeface="Consolas"/>
+              </a:rPr>
+              <a:t>&lt;</a:t>
+            </a:r>
+            <a:r>
+              <a:rPr sz="1600">
+                <a:solidFill>
+                  <a:srgbClr val="4EC9B0"/>
+                </a:solidFill>
+                <a:latin typeface="Consolas"/>
+              </a:rPr>
+              <a:t>Self</a:t>
+            </a:r>
+            <a:r>
+              <a:rPr sz="1600">
+                <a:solidFill>
+                  <a:srgbClr val="DCDCDC"/>
+                </a:solidFill>
+                <a:latin typeface="Consolas"/>
+              </a:rPr>
+              <a:t>&gt;</a:t>
+            </a:r>
+            <a:r>
+              <a:rPr sz="1600">
+                <a:solidFill>
+                  <a:srgbClr val="DCDCDC"/>
+                </a:solidFill>
+                <a:latin typeface="Consolas"/>
+              </a:rPr>
+              <a:t> </a:t>
+            </a:r>
+            <a:r>
+              <a:rPr sz="1600">
+                <a:solidFill>
+                  <a:srgbClr val="DCDCDC"/>
+                </a:solidFill>
+                <a:latin typeface="Consolas"/>
+              </a:rPr>
+              <a:t>{</a:t>
             </a:r>
           </a:p>
           <a:p>
@@ -4085,16 +4220,70 @@
                 </a:solidFill>
                 <a:latin typeface="Consolas"/>
               </a:rPr>
-              <a:t>    </a:t>
-            </a:r>
-            <a:r>
-              <a:rPr sz="1600">
-                <a:solidFill>
-                  <a:srgbClr val="C586C0"/>
-                </a:solidFill>
-                <a:latin typeface="Consolas"/>
-              </a:rPr>
-              <a:t>fn</a:t>
+              <a:t>        </a:t>
+            </a:r>
+            <a:r>
+              <a:rPr sz="1600">
+                <a:solidFill>
+                  <a:srgbClr val="DCDCAA"/>
+                </a:solidFill>
+                <a:latin typeface="Consolas"/>
+              </a:rPr>
+              <a:t>debug_assert!</a:t>
+            </a:r>
+            <a:r>
+              <a:rPr sz="1600">
+                <a:solidFill>
+                  <a:srgbClr val="DCDCDC"/>
+                </a:solidFill>
+                <a:latin typeface="Consolas"/>
+              </a:rPr>
+              <a:t>(</a:t>
+            </a:r>
+            <a:r>
+              <a:rPr sz="1600">
+                <a:solidFill>
+                  <a:srgbClr val="4EC9B0"/>
+                </a:solidFill>
+                <a:latin typeface="Consolas"/>
+              </a:rPr>
+              <a:t>Self</a:t>
+            </a:r>
+            <a:r>
+              <a:rPr sz="1600">
+                <a:solidFill>
+                  <a:srgbClr val="DCDCDC"/>
+                </a:solidFill>
+                <a:latin typeface="Consolas"/>
+              </a:rPr>
+              <a:t>::</a:t>
+            </a:r>
+            <a:r>
+              <a:rPr sz="1600">
+                <a:solidFill>
+                  <a:srgbClr val="DCDCDC"/>
+                </a:solidFill>
+                <a:latin typeface="Consolas"/>
+              </a:rPr>
+              <a:t>min_value</a:t>
+            </a:r>
+            <a:r>
+              <a:rPr sz="1600">
+                <a:solidFill>
+                  <a:srgbClr val="DCDCDC"/>
+                </a:solidFill>
+                <a:latin typeface="Consolas"/>
+              </a:rPr>
+              <a:t>(</a:t>
+            </a:r>
+            <a:r>
+              <a:rPr sz="1600">
+                <a:solidFill>
+                  <a:srgbClr val="DCDCDC"/>
+                </a:solidFill>
+                <a:latin typeface="Consolas"/>
+              </a:rPr>
+              <a:t>)</a:t>
             </a:r>
             <a:r>
               <a:rPr sz="1600">
@@ -4108,11 +4297,47 @@
             <a:r>
               <a:rPr sz="1600">
                 <a:solidFill>
-                  <a:srgbClr val="DCDCAA"/>
-                </a:solidFill>
-                <a:latin typeface="Consolas"/>
-              </a:rPr>
-              <a:t>exhausted_range</a:t>
+                  <a:srgbClr val="DCDCDC"/>
+                </a:solidFill>
+                <a:latin typeface="Consolas"/>
+              </a:rPr>
+              <a:t>&lt;</a:t>
+            </a:r>
+            <a:r>
+              <a:rPr sz="1600">
+                <a:solidFill>
+                  <a:srgbClr val="DCDCDC"/>
+                </a:solidFill>
+                <a:latin typeface="Consolas"/>
+              </a:rPr>
+              <a:t> </a:t>
+            </a:r>
+            <a:r>
+              <a:rPr sz="1600">
+                <a:solidFill>
+                  <a:srgbClr val="4EC9B0"/>
+                </a:solidFill>
+                <a:latin typeface="Consolas"/>
+              </a:rPr>
+              <a:t>Self</a:t>
+            </a:r>
+            <a:r>
+              <a:rPr sz="1600">
+                <a:solidFill>
+                  <a:srgbClr val="DCDCDC"/>
+                </a:solidFill>
+                <a:latin typeface="Consolas"/>
+              </a:rPr>
+              <a:t>::</a:t>
+            </a:r>
+            <a:r>
+              <a:rPr sz="1600">
+                <a:solidFill>
+                  <a:srgbClr val="DCDCDC"/>
+                </a:solidFill>
+                <a:latin typeface="Consolas"/>
+              </a:rPr>
+              <a:t>max_value</a:t>
             </a:r>
             <a:r>
               <a:rPr sz="1600">
@@ -4139,79 +4364,61 @@
                 </a:solidFill>
                 <a:latin typeface="Consolas"/>
               </a:rPr>
+              <a:t>,</a:t>
+            </a:r>
+            <a:r>
+              <a:rPr sz="1600">
+                <a:solidFill>
+                  <a:srgbClr val="DCDCDC"/>
+                </a:solidFill>
+                <a:latin typeface="Consolas"/>
+              </a:rPr>
               <a:t> </a:t>
             </a:r>
             <a:r>
               <a:rPr sz="1600">
                 <a:solidFill>
-                  <a:srgbClr val="DCDCDC"/>
-                </a:solidFill>
-                <a:latin typeface="Consolas"/>
-              </a:rPr>
-              <a:t>-&gt;</a:t>
-            </a:r>
-            <a:r>
-              <a:rPr sz="1600">
-                <a:solidFill>
-                  <a:srgbClr val="DCDCDC"/>
-                </a:solidFill>
-                <a:latin typeface="Consolas"/>
-              </a:rPr>
-              <a:t> </a:t>
-            </a:r>
-            <a:r>
-              <a:rPr sz="1600">
-                <a:solidFill>
-                  <a:srgbClr val="4EC9B0"/>
-                </a:solidFill>
-                <a:latin typeface="Consolas"/>
-              </a:rPr>
-              <a:t>RangeInclusive</a:t>
-            </a:r>
-            <a:r>
-              <a:rPr sz="1600">
-                <a:solidFill>
-                  <a:srgbClr val="DCDCDC"/>
-                </a:solidFill>
-                <a:latin typeface="Consolas"/>
-              </a:rPr>
-              <a:t>&lt;</a:t>
-            </a:r>
-            <a:r>
-              <a:rPr sz="1600">
-                <a:solidFill>
-                  <a:srgbClr val="4EC9B0"/>
-                </a:solidFill>
-                <a:latin typeface="Consolas"/>
-              </a:rPr>
-              <a:t>Self</a:t>
-            </a:r>
-            <a:r>
-              <a:rPr sz="1600">
-                <a:solidFill>
-                  <a:srgbClr val="DCDCDC"/>
-                </a:solidFill>
-                <a:latin typeface="Consolas"/>
-              </a:rPr>
-              <a:t>&gt;</a:t>
-            </a:r>
-            <a:r>
-              <a:rPr sz="1600">
-                <a:solidFill>
-                  <a:srgbClr val="DCDCDC"/>
-                </a:solidFill>
-                <a:latin typeface="Consolas"/>
-              </a:rPr>
-              <a:t> </a:t>
-            </a:r>
-            <a:r>
-              <a:rPr sz="1600">
-                <a:solidFill>
-                  <a:srgbClr val="DCDCDC"/>
-                </a:solidFill>
-                <a:latin typeface="Consolas"/>
-              </a:rPr>
-              <a:t>{</a:t>
+                  <a:srgbClr val="CE9178"/>
+                </a:solidFill>
+                <a:latin typeface="Consolas"/>
+              </a:rPr>
+              <a:t>"</a:t>
+            </a:r>
+            <a:r>
+              <a:rPr sz="1600">
+                <a:solidFill>
+                  <a:srgbClr val="CE9178"/>
+                </a:solidFill>
+                <a:latin typeface="Consolas"/>
+              </a:rPr>
+              <a:t>Precondition</a:t>
+            </a:r>
+            <a:r>
+              <a:rPr sz="1600">
+                <a:solidFill>
+                  <a:srgbClr val="CE9178"/>
+                </a:solidFill>
+                <a:latin typeface="Consolas"/>
+              </a:rPr>
+              <a:t>"</a:t>
+            </a:r>
+            <a:r>
+              <a:rPr sz="1600">
+                <a:solidFill>
+                  <a:srgbClr val="DCDCDC"/>
+                </a:solidFill>
+                <a:latin typeface="Consolas"/>
+              </a:rPr>
+              <a:t>)</a:t>
+            </a:r>
+            <a:r>
+              <a:rPr sz="1600">
+                <a:solidFill>
+                  <a:srgbClr val="DCDCDC"/>
+                </a:solidFill>
+                <a:latin typeface="Consolas"/>
+              </a:rPr>
+              <a:t>;</a:t>
             </a:r>
           </a:p>
           <a:p>
@@ -4238,11 +4445,29 @@
             <a:r>
               <a:rPr sz="1600">
                 <a:solidFill>
-                  <a:srgbClr val="DCDCAA"/>
-                </a:solidFill>
-                <a:latin typeface="Consolas"/>
-              </a:rPr>
-              <a:t>debug_assert!</a:t>
+                  <a:srgbClr val="4EC9B0"/>
+                </a:solidFill>
+                <a:latin typeface="Consolas"/>
+              </a:rPr>
+              <a:t>Self</a:t>
+            </a:r>
+            <a:r>
+              <a:rPr sz="1600">
+                <a:solidFill>
+                  <a:srgbClr val="DCDCDC"/>
+                </a:solidFill>
+                <a:latin typeface="Consolas"/>
+              </a:rPr>
+              <a:t>::</a:t>
+            </a:r>
+            <a:r>
+              <a:rPr sz="1600">
+                <a:solidFill>
+                  <a:srgbClr val="DCDCDC"/>
+                </a:solidFill>
+                <a:latin typeface="Consolas"/>
+              </a:rPr>
+              <a:t>max_value</a:t>
             </a:r>
             <a:r>
               <a:rPr sz="1600">
@@ -4256,6 +4481,24 @@
             <a:r>
               <a:rPr sz="1600">
                 <a:solidFill>
+                  <a:srgbClr val="DCDCDC"/>
+                </a:solidFill>
+                <a:latin typeface="Consolas"/>
+              </a:rPr>
+              <a:t>)</a:t>
+            </a:r>
+            <a:r>
+              <a:rPr sz="1600">
+                <a:solidFill>
+                  <a:srgbClr val="DCDCDC"/>
+                </a:solidFill>
+                <a:latin typeface="Consolas"/>
+              </a:rPr>
+              <a:t>..=</a:t>
+            </a:r>
+            <a:r>
+              <a:rPr sz="1600">
+                <a:solidFill>
                   <a:srgbClr val="4EC9B0"/>
                 </a:solidFill>
                 <a:latin typeface="Consolas"/>
@@ -4297,141 +4540,6 @@
                 <a:latin typeface="Consolas"/>
               </a:rPr>
               <a:t>)</a:t>
-            </a:r>
-            <a:r>
-              <a:rPr sz="1600">
-                <a:solidFill>
-                  <a:srgbClr val="DCDCDC"/>
-                </a:solidFill>
-                <a:latin typeface="Consolas"/>
-              </a:rPr>
-              <a:t> </a:t>
-            </a:r>
-            <a:r>
-              <a:rPr sz="1600">
-                <a:solidFill>
-                  <a:srgbClr val="DCDCDC"/>
-                </a:solidFill>
-                <a:latin typeface="Consolas"/>
-              </a:rPr>
-              <a:t>&lt;</a:t>
-            </a:r>
-            <a:r>
-              <a:rPr sz="1600">
-                <a:solidFill>
-                  <a:srgbClr val="DCDCDC"/>
-                </a:solidFill>
-                <a:latin typeface="Consolas"/>
-              </a:rPr>
-              <a:t> </a:t>
-            </a:r>
-            <a:r>
-              <a:rPr sz="1600">
-                <a:solidFill>
-                  <a:srgbClr val="4EC9B0"/>
-                </a:solidFill>
-                <a:latin typeface="Consolas"/>
-              </a:rPr>
-              <a:t>Self</a:t>
-            </a:r>
-            <a:r>
-              <a:rPr sz="1600">
-                <a:solidFill>
-                  <a:srgbClr val="DCDCDC"/>
-                </a:solidFill>
-                <a:latin typeface="Consolas"/>
-              </a:rPr>
-              <a:t>::</a:t>
-            </a:r>
-            <a:r>
-              <a:rPr sz="1600">
-                <a:solidFill>
-                  <a:srgbClr val="DCDCDC"/>
-                </a:solidFill>
-                <a:latin typeface="Consolas"/>
-              </a:rPr>
-              <a:t>max_value</a:t>
-            </a:r>
-            <a:r>
-              <a:rPr sz="1600">
-                <a:solidFill>
-                  <a:srgbClr val="DCDCDC"/>
-                </a:solidFill>
-                <a:latin typeface="Consolas"/>
-              </a:rPr>
-              <a:t>(</a:t>
-            </a:r>
-            <a:r>
-              <a:rPr sz="1600">
-                <a:solidFill>
-                  <a:srgbClr val="DCDCDC"/>
-                </a:solidFill>
-                <a:latin typeface="Consolas"/>
-              </a:rPr>
-              <a:t>)</a:t>
-            </a:r>
-            <a:r>
-              <a:rPr sz="1600">
-                <a:solidFill>
-                  <a:srgbClr val="DCDCDC"/>
-                </a:solidFill>
-                <a:latin typeface="Consolas"/>
-              </a:rPr>
-              <a:t>,</a:t>
-            </a:r>
-            <a:r>
-              <a:rPr sz="1600">
-                <a:solidFill>
-                  <a:srgbClr val="DCDCDC"/>
-                </a:solidFill>
-                <a:latin typeface="Consolas"/>
-              </a:rPr>
-              <a:t> </a:t>
-            </a:r>
-            <a:r>
-              <a:rPr sz="1600">
-                <a:solidFill>
-                  <a:srgbClr val="CE9178"/>
-                </a:solidFill>
-                <a:latin typeface="Consolas"/>
-              </a:rPr>
-              <a:t>"</a:t>
-            </a:r>
-            <a:r>
-              <a:rPr sz="1600">
-                <a:solidFill>
-                  <a:srgbClr val="CE9178"/>
-                </a:solidFill>
-                <a:latin typeface="Consolas"/>
-              </a:rPr>
-              <a:t>Precondition violated: min_value must be less than max_value</a:t>
-            </a:r>
-            <a:r>
-              <a:rPr sz="1600">
-                <a:solidFill>
-                  <a:srgbClr val="CE9178"/>
-                </a:solidFill>
-                <a:latin typeface="Consolas"/>
-              </a:rPr>
-              <a:t>"</a:t>
-            </a:r>
-            <a:r>
-              <a:rPr sz="1600">
-                <a:solidFill>
-                  <a:srgbClr val="DCDCDC"/>
-                </a:solidFill>
-                <a:latin typeface="Consolas"/>
-              </a:rPr>
-              <a:t>)</a:t>
-            </a:r>
-            <a:r>
-              <a:rPr sz="1600">
-                <a:solidFill>
-                  <a:srgbClr val="DCDCDC"/>
-                </a:solidFill>
-                <a:latin typeface="Consolas"/>
-              </a:rPr>
-              <a:t>;</a:t>
             </a:r>
           </a:p>
           <a:p>
@@ -4453,106 +4561,16 @@
                 </a:solidFill>
                 <a:latin typeface="Consolas"/>
               </a:rPr>
-              <a:t>        </a:t>
-            </a:r>
-            <a:r>
-              <a:rPr sz="1600">
-                <a:solidFill>
-                  <a:srgbClr val="4EC9B0"/>
-                </a:solidFill>
-                <a:latin typeface="Consolas"/>
-              </a:rPr>
-              <a:t>Self</a:t>
-            </a:r>
-            <a:r>
-              <a:rPr sz="1600">
-                <a:solidFill>
-                  <a:srgbClr val="DCDCDC"/>
-                </a:solidFill>
-                <a:latin typeface="Consolas"/>
-              </a:rPr>
-              <a:t>::</a:t>
-            </a:r>
-            <a:r>
-              <a:rPr sz="1600">
-                <a:solidFill>
-                  <a:srgbClr val="DCDCDC"/>
-                </a:solidFill>
-                <a:latin typeface="Consolas"/>
-              </a:rPr>
-              <a:t>max_value</a:t>
-            </a:r>
-            <a:r>
-              <a:rPr sz="1600">
-                <a:solidFill>
-                  <a:srgbClr val="DCDCDC"/>
-                </a:solidFill>
-                <a:latin typeface="Consolas"/>
-              </a:rPr>
-              <a:t>(</a:t>
-            </a:r>
-            <a:r>
-              <a:rPr sz="1600">
-                <a:solidFill>
-                  <a:srgbClr val="DCDCDC"/>
-                </a:solidFill>
-                <a:latin typeface="Consolas"/>
-              </a:rPr>
-              <a:t>)</a:t>
-            </a:r>
-            <a:r>
-              <a:rPr sz="1600">
-                <a:solidFill>
-                  <a:srgbClr val="DCDCDC"/>
-                </a:solidFill>
-                <a:latin typeface="Consolas"/>
-              </a:rPr>
-              <a:t>..=</a:t>
-            </a:r>
-            <a:r>
-              <a:rPr sz="1600">
-                <a:solidFill>
-                  <a:srgbClr val="4EC9B0"/>
-                </a:solidFill>
-                <a:latin typeface="Consolas"/>
-              </a:rPr>
-              <a:t>Self</a:t>
-            </a:r>
-            <a:r>
-              <a:rPr sz="1600">
-                <a:solidFill>
-                  <a:srgbClr val="DCDCDC"/>
-                </a:solidFill>
-                <a:latin typeface="Consolas"/>
-              </a:rPr>
-              <a:t>::</a:t>
-            </a:r>
-            <a:r>
-              <a:rPr sz="1600">
-                <a:solidFill>
-                  <a:srgbClr val="DCDCDC"/>
-                </a:solidFill>
-                <a:latin typeface="Consolas"/>
-              </a:rPr>
-              <a:t>min_value</a:t>
-            </a:r>
-            <a:r>
-              <a:rPr sz="1600">
-                <a:solidFill>
-                  <a:srgbClr val="DCDCDC"/>
-                </a:solidFill>
-                <a:latin typeface="Consolas"/>
-              </a:rPr>
-              <a:t>(</a:t>
-            </a:r>
-            <a:r>
-              <a:rPr sz="1600">
-                <a:solidFill>
-                  <a:srgbClr val="DCDCDC"/>
-                </a:solidFill>
-                <a:latin typeface="Consolas"/>
-              </a:rPr>
-              <a:t>)</a:t>
+              <a:t>    </a:t>
+            </a:r>
+            <a:r>
+              <a:rPr sz="1600">
+                <a:solidFill>
+                  <a:srgbClr val="DCDCDC"/>
+                </a:solidFill>
+                <a:latin typeface="Consolas"/>
+              </a:rPr>
+              <a:t>}</a:t>
             </a:r>
           </a:p>
           <a:p>
@@ -4574,15 +4592,6 @@
                 </a:solidFill>
                 <a:latin typeface="Consolas"/>
               </a:rPr>
-              <a:t>    </a:t>
-            </a:r>
-            <a:r>
-              <a:rPr sz="1600">
-                <a:solidFill>
-                  <a:srgbClr val="DCDCDC"/>
-                </a:solidFill>
-                <a:latin typeface="Consolas"/>
-              </a:rPr>
               <a:t>}</a:t>
             </a:r>
           </a:p>
@@ -4598,15 +4607,6 @@
                 <a:spcPts val="0"/>
               </a:spcAft>
             </a:pPr>
-            <a:r>
-              <a:rPr sz="1600">
-                <a:solidFill>
-                  <a:srgbClr val="DCDCDC"/>
-                </a:solidFill>
-                <a:latin typeface="Consolas"/>
-              </a:rPr>
-              <a:t>}</a:t>
-            </a:r>
           </a:p>
           <a:p>
             <a:pPr>
@@ -4620,6 +4620,87 @@
                 <a:spcPts val="0"/>
               </a:spcAft>
             </a:pPr>
+            <a:r>
+              <a:rPr sz="1600">
+                <a:solidFill>
+                  <a:srgbClr val="C586C0"/>
+                </a:solidFill>
+                <a:latin typeface="Consolas"/>
+              </a:rPr>
+              <a:t>impl</a:t>
+            </a:r>
+            <a:r>
+              <a:rPr sz="1600">
+                <a:solidFill>
+                  <a:srgbClr val="DCDCDC"/>
+                </a:solidFill>
+                <a:latin typeface="Consolas"/>
+              </a:rPr>
+              <a:t> </a:t>
+            </a:r>
+            <a:r>
+              <a:rPr sz="1600">
+                <a:solidFill>
+                  <a:srgbClr val="DCDCDC"/>
+                </a:solidFill>
+                <a:latin typeface="Consolas"/>
+              </a:rPr>
+              <a:t>Integer</a:t>
+            </a:r>
+            <a:r>
+              <a:rPr sz="1600">
+                <a:solidFill>
+                  <a:srgbClr val="DCDCDC"/>
+                </a:solidFill>
+                <a:latin typeface="Consolas"/>
+              </a:rPr>
+              <a:t> </a:t>
+            </a:r>
+            <a:r>
+              <a:rPr sz="1600">
+                <a:solidFill>
+                  <a:srgbClr val="C586C0"/>
+                </a:solidFill>
+                <a:latin typeface="Consolas"/>
+              </a:rPr>
+              <a:t>for</a:t>
+            </a:r>
+            <a:r>
+              <a:rPr sz="1600">
+                <a:solidFill>
+                  <a:srgbClr val="DCDCDC"/>
+                </a:solidFill>
+                <a:latin typeface="Consolas"/>
+              </a:rPr>
+              <a:t> </a:t>
+            </a:r>
+            <a:r>
+              <a:rPr sz="1600">
+                <a:solidFill>
+                  <a:srgbClr val="C586C0"/>
+                </a:solidFill>
+                <a:latin typeface="Consolas"/>
+              </a:rPr>
+              <a:t>u8</a:t>
+            </a:r>
+            <a:r>
+              <a:rPr sz="1600">
+                <a:solidFill>
+                  <a:srgbClr val="DCDCDC"/>
+                </a:solidFill>
+                <a:latin typeface="Consolas"/>
+              </a:rPr>
+              <a:t> </a:t>
+            </a:r>
+            <a:r>
+              <a:rPr sz="1600">
+                <a:solidFill>
+                  <a:srgbClr val="DCDCDC"/>
+                </a:solidFill>
+                <a:latin typeface="Consolas"/>
+              </a:rPr>
+              <a:t>{</a:t>
+            </a:r>
           </a:p>
           <a:p>
             <a:pPr>
@@ -4636,11 +4717,20 @@
             <a:r>
               <a:rPr sz="1600">
                 <a:solidFill>
+                  <a:srgbClr val="DCDCDC"/>
+                </a:solidFill>
+                <a:latin typeface="Consolas"/>
+              </a:rPr>
+              <a:t>    </a:t>
+            </a:r>
+            <a:r>
+              <a:rPr sz="1600">
+                <a:solidFill>
                   <a:srgbClr val="C586C0"/>
                 </a:solidFill>
                 <a:latin typeface="Consolas"/>
               </a:rPr>
-              <a:t>impl</a:t>
+              <a:t>fn</a:t>
             </a:r>
             <a:r>
               <a:rPr sz="1600">
@@ -4654,11 +4744,29 @@
             <a:r>
               <a:rPr sz="1600">
                 <a:solidFill>
-                  <a:srgbClr val="DCDCDC"/>
-                </a:solidFill>
-                <a:latin typeface="Consolas"/>
-              </a:rPr>
-              <a:t>Integer</a:t>
+                  <a:srgbClr val="DCDCAA"/>
+                </a:solidFill>
+                <a:latin typeface="Consolas"/>
+              </a:rPr>
+              <a:t>min_value</a:t>
+            </a:r>
+            <a:r>
+              <a:rPr sz="1600">
+                <a:solidFill>
+                  <a:srgbClr val="DCDCDC"/>
+                </a:solidFill>
+                <a:latin typeface="Consolas"/>
+              </a:rPr>
+              <a:t>(</a:t>
+            </a:r>
+            <a:r>
+              <a:rPr sz="1600">
+                <a:solidFill>
+                  <a:srgbClr val="DCDCDC"/>
+                </a:solidFill>
+                <a:latin typeface="Consolas"/>
+              </a:rPr>
+              <a:t>)</a:t>
             </a:r>
             <a:r>
               <a:rPr sz="1600">
@@ -4672,11 +4780,11 @@
             <a:r>
               <a:rPr sz="1600">
                 <a:solidFill>
-                  <a:srgbClr val="C586C0"/>
-                </a:solidFill>
-                <a:latin typeface="Consolas"/>
-              </a:rPr>
-              <a:t>for</a:t>
+                  <a:srgbClr val="DCDCDC"/>
+                </a:solidFill>
+                <a:latin typeface="Consolas"/>
+              </a:rPr>
+              <a:t>-&gt;</a:t>
             </a:r>
             <a:r>
               <a:rPr sz="1600">
@@ -4690,11 +4798,11 @@
             <a:r>
               <a:rPr sz="1600">
                 <a:solidFill>
-                  <a:srgbClr val="C586C0"/>
-                </a:solidFill>
-                <a:latin typeface="Consolas"/>
-              </a:rPr>
-              <a:t>u8</a:t>
+                  <a:srgbClr val="4EC9B0"/>
+                </a:solidFill>
+                <a:latin typeface="Consolas"/>
+              </a:rPr>
+              <a:t>Self</a:t>
             </a:r>
             <a:r>
               <a:rPr sz="1600">
@@ -4734,7 +4842,7 @@
                 </a:solidFill>
                 <a:latin typeface="Consolas"/>
               </a:rPr>
-              <a:t>    </a:t>
+              <a:t>        </a:t>
             </a:r>
             <a:r>
               <a:rPr sz="1600">
@@ -4743,97 +4851,25 @@
                 </a:solidFill>
                 <a:latin typeface="Consolas"/>
               </a:rPr>
-              <a:t>fn</a:t>
-            </a:r>
-            <a:r>
-              <a:rPr sz="1600">
-                <a:solidFill>
-                  <a:srgbClr val="DCDCDC"/>
-                </a:solidFill>
-                <a:latin typeface="Consolas"/>
-              </a:rPr>
-              <a:t> </a:t>
-            </a:r>
-            <a:r>
-              <a:rPr sz="1600">
-                <a:solidFill>
-                  <a:srgbClr val="DCDCAA"/>
-                </a:solidFill>
-                <a:latin typeface="Consolas"/>
-              </a:rPr>
-              <a:t>min_value</a:t>
-            </a:r>
-            <a:r>
-              <a:rPr sz="1600">
-                <a:solidFill>
-                  <a:srgbClr val="DCDCDC"/>
-                </a:solidFill>
-                <a:latin typeface="Consolas"/>
-              </a:rPr>
-              <a:t>(</a:t>
-            </a:r>
-            <a:r>
-              <a:rPr sz="1600">
-                <a:solidFill>
-                  <a:srgbClr val="DCDCDC"/>
-                </a:solidFill>
-                <a:latin typeface="Consolas"/>
-              </a:rPr>
-              <a:t>)</a:t>
-            </a:r>
-            <a:r>
-              <a:rPr sz="1600">
-                <a:solidFill>
-                  <a:srgbClr val="DCDCDC"/>
-                </a:solidFill>
-                <a:latin typeface="Consolas"/>
-              </a:rPr>
-              <a:t> </a:t>
-            </a:r>
-            <a:r>
-              <a:rPr sz="1600">
-                <a:solidFill>
-                  <a:srgbClr val="DCDCDC"/>
-                </a:solidFill>
-                <a:latin typeface="Consolas"/>
-              </a:rPr>
-              <a:t>-&gt;</a:t>
-            </a:r>
-            <a:r>
-              <a:rPr sz="1600">
-                <a:solidFill>
-                  <a:srgbClr val="DCDCDC"/>
-                </a:solidFill>
-                <a:latin typeface="Consolas"/>
-              </a:rPr>
-              <a:t> </a:t>
-            </a:r>
-            <a:r>
-              <a:rPr sz="1600">
-                <a:solidFill>
-                  <a:srgbClr val="4EC9B0"/>
-                </a:solidFill>
-                <a:latin typeface="Consolas"/>
-              </a:rPr>
-              <a:t>Self</a:t>
-            </a:r>
-            <a:r>
-              <a:rPr sz="1600">
-                <a:solidFill>
-                  <a:srgbClr val="DCDCDC"/>
-                </a:solidFill>
-                <a:latin typeface="Consolas"/>
-              </a:rPr>
-              <a:t> </a:t>
-            </a:r>
-            <a:r>
-              <a:rPr sz="1600">
-                <a:solidFill>
-                  <a:srgbClr val="DCDCDC"/>
-                </a:solidFill>
-                <a:latin typeface="Consolas"/>
-              </a:rPr>
-              <a:t>{</a:t>
+              <a:t>u8</a:t>
+            </a:r>
+            <a:r>
+              <a:rPr sz="1600">
+                <a:solidFill>
+                  <a:srgbClr val="DCDCDC"/>
+                </a:solidFill>
+                <a:latin typeface="Consolas"/>
+              </a:rPr>
+              <a:t>::</a:t>
+            </a:r>
+            <a:r>
+              <a:rPr sz="1600">
+                <a:solidFill>
+                  <a:srgbClr val="DCDCDC"/>
+                </a:solidFill>
+                <a:latin typeface="Consolas"/>
+              </a:rPr>
+              <a:t>MIN</a:t>
             </a:r>
           </a:p>
           <a:p>
@@ -4855,34 +4891,16 @@
                 </a:solidFill>
                 <a:latin typeface="Consolas"/>
               </a:rPr>
-              <a:t>        </a:t>
-            </a:r>
-            <a:r>
-              <a:rPr sz="1600">
-                <a:solidFill>
-                  <a:srgbClr val="C586C0"/>
-                </a:solidFill>
-                <a:latin typeface="Consolas"/>
-              </a:rPr>
-              <a:t>u8</a:t>
-            </a:r>
-            <a:r>
-              <a:rPr sz="1600">
-                <a:solidFill>
-                  <a:srgbClr val="DCDCDC"/>
-                </a:solidFill>
-                <a:latin typeface="Consolas"/>
-              </a:rPr>
-              <a:t>::</a:t>
-            </a:r>
-            <a:r>
-              <a:rPr sz="1600">
-                <a:solidFill>
-                  <a:srgbClr val="DCDCDC"/>
-                </a:solidFill>
-                <a:latin typeface="Consolas"/>
-              </a:rPr>
-              <a:t>MIN</a:t>
+              <a:t>    </a:t>
+            </a:r>
+            <a:r>
+              <a:rPr sz="1600">
+                <a:solidFill>
+                  <a:srgbClr val="DCDCDC"/>
+                </a:solidFill>
+                <a:latin typeface="Consolas"/>
+              </a:rPr>
+              <a:t>}</a:t>
             </a:r>
           </a:p>
           <a:p>
@@ -4897,24 +4915,6 @@
                 <a:spcPts val="0"/>
               </a:spcAft>
             </a:pPr>
-            <a:r>
-              <a:rPr sz="1600">
-                <a:solidFill>
-                  <a:srgbClr val="DCDCDC"/>
-                </a:solidFill>
-                <a:latin typeface="Consolas"/>
-              </a:rPr>
-              <a:t>    </a:t>
-            </a:r>
-            <a:r>
-              <a:rPr sz="1600">
-                <a:solidFill>
-                  <a:srgbClr val="DCDCDC"/>
-                </a:solidFill>
-                <a:latin typeface="Consolas"/>
-              </a:rPr>
-              <a:t>}</a:t>
-            </a:r>
           </a:p>
           <a:p>
             <a:pPr>
@@ -4928,6 +4928,114 @@
                 <a:spcPts val="0"/>
               </a:spcAft>
             </a:pPr>
+            <a:r>
+              <a:rPr sz="1600">
+                <a:solidFill>
+                  <a:srgbClr val="DCDCDC"/>
+                </a:solidFill>
+                <a:latin typeface="Consolas"/>
+              </a:rPr>
+              <a:t>    </a:t>
+            </a:r>
+            <a:r>
+              <a:rPr sz="1600">
+                <a:solidFill>
+                  <a:srgbClr val="C586C0"/>
+                </a:solidFill>
+                <a:latin typeface="Consolas"/>
+              </a:rPr>
+              <a:t>fn</a:t>
+            </a:r>
+            <a:r>
+              <a:rPr sz="1600">
+                <a:solidFill>
+                  <a:srgbClr val="DCDCDC"/>
+                </a:solidFill>
+                <a:latin typeface="Consolas"/>
+              </a:rPr>
+              <a:t> </a:t>
+            </a:r>
+            <a:r>
+              <a:rPr sz="1600">
+                <a:solidFill>
+                  <a:srgbClr val="DCDCAA"/>
+                </a:solidFill>
+                <a:latin typeface="Consolas"/>
+              </a:rPr>
+              <a:t>max_value</a:t>
+            </a:r>
+            <a:r>
+              <a:rPr sz="1600">
+                <a:solidFill>
+                  <a:srgbClr val="DCDCDC"/>
+                </a:solidFill>
+                <a:latin typeface="Consolas"/>
+              </a:rPr>
+              <a:t>(</a:t>
+            </a:r>
+            <a:r>
+              <a:rPr sz="1600">
+                <a:solidFill>
+                  <a:srgbClr val="DCDCDC"/>
+                </a:solidFill>
+                <a:latin typeface="Consolas"/>
+              </a:rPr>
+              <a:t>)</a:t>
+            </a:r>
+            <a:r>
+              <a:rPr sz="1600">
+                <a:solidFill>
+                  <a:srgbClr val="DCDCDC"/>
+                </a:solidFill>
+                <a:latin typeface="Consolas"/>
+              </a:rPr>
+              <a:t> </a:t>
+            </a:r>
+            <a:r>
+              <a:rPr sz="1600">
+                <a:solidFill>
+                  <a:srgbClr val="DCDCDC"/>
+                </a:solidFill>
+                <a:latin typeface="Consolas"/>
+              </a:rPr>
+              <a:t>-&gt;</a:t>
+            </a:r>
+            <a:r>
+              <a:rPr sz="1600">
+                <a:solidFill>
+                  <a:srgbClr val="DCDCDC"/>
+                </a:solidFill>
+                <a:latin typeface="Consolas"/>
+              </a:rPr>
+              <a:t> </a:t>
+            </a:r>
+            <a:r>
+              <a:rPr sz="1600">
+                <a:solidFill>
+                  <a:srgbClr val="4EC9B0"/>
+                </a:solidFill>
+                <a:latin typeface="Consolas"/>
+              </a:rPr>
+              <a:t>Self</a:t>
+            </a:r>
+            <a:r>
+              <a:rPr sz="1600">
+                <a:solidFill>
+                  <a:srgbClr val="DCDCDC"/>
+                </a:solidFill>
+                <a:latin typeface="Consolas"/>
+              </a:rPr>
+              <a:t> </a:t>
+            </a:r>
+            <a:r>
+              <a:rPr sz="1600">
+                <a:solidFill>
+                  <a:srgbClr val="DCDCDC"/>
+                </a:solidFill>
+                <a:latin typeface="Consolas"/>
+              </a:rPr>
+              <a:t>{</a:t>
+            </a:r>
           </a:p>
           <a:p>
             <a:pPr>
@@ -4948,7 +5056,7 @@
                 </a:solidFill>
                 <a:latin typeface="Consolas"/>
               </a:rPr>
-              <a:t>    </a:t>
+              <a:t>        </a:t>
             </a:r>
             <a:r>
               <a:rPr sz="1600">
@@ -4957,97 +5065,25 @@
                 </a:solidFill>
                 <a:latin typeface="Consolas"/>
               </a:rPr>
-              <a:t>fn</a:t>
-            </a:r>
-            <a:r>
-              <a:rPr sz="1600">
-                <a:solidFill>
-                  <a:srgbClr val="DCDCDC"/>
-                </a:solidFill>
-                <a:latin typeface="Consolas"/>
-              </a:rPr>
-              <a:t> </a:t>
-            </a:r>
-            <a:r>
-              <a:rPr sz="1600">
-                <a:solidFill>
-                  <a:srgbClr val="DCDCAA"/>
-                </a:solidFill>
-                <a:latin typeface="Consolas"/>
-              </a:rPr>
-              <a:t>max_value</a:t>
-            </a:r>
-            <a:r>
-              <a:rPr sz="1600">
-                <a:solidFill>
-                  <a:srgbClr val="DCDCDC"/>
-                </a:solidFill>
-                <a:latin typeface="Consolas"/>
-              </a:rPr>
-              <a:t>(</a:t>
-            </a:r>
-            <a:r>
-              <a:rPr sz="1600">
-                <a:solidFill>
-                  <a:srgbClr val="DCDCDC"/>
-                </a:solidFill>
-                <a:latin typeface="Consolas"/>
-              </a:rPr>
-              <a:t>)</a:t>
-            </a:r>
-            <a:r>
-              <a:rPr sz="1600">
-                <a:solidFill>
-                  <a:srgbClr val="DCDCDC"/>
-                </a:solidFill>
-                <a:latin typeface="Consolas"/>
-              </a:rPr>
-              <a:t> </a:t>
-            </a:r>
-            <a:r>
-              <a:rPr sz="1600">
-                <a:solidFill>
-                  <a:srgbClr val="DCDCDC"/>
-                </a:solidFill>
-                <a:latin typeface="Consolas"/>
-              </a:rPr>
-              <a:t>-&gt;</a:t>
-            </a:r>
-            <a:r>
-              <a:rPr sz="1600">
-                <a:solidFill>
-                  <a:srgbClr val="DCDCDC"/>
-                </a:solidFill>
-                <a:latin typeface="Consolas"/>
-              </a:rPr>
-              <a:t> </a:t>
-            </a:r>
-            <a:r>
-              <a:rPr sz="1600">
-                <a:solidFill>
-                  <a:srgbClr val="4EC9B0"/>
-                </a:solidFill>
-                <a:latin typeface="Consolas"/>
-              </a:rPr>
-              <a:t>Self</a:t>
-            </a:r>
-            <a:r>
-              <a:rPr sz="1600">
-                <a:solidFill>
-                  <a:srgbClr val="DCDCDC"/>
-                </a:solidFill>
-                <a:latin typeface="Consolas"/>
-              </a:rPr>
-              <a:t> </a:t>
-            </a:r>
-            <a:r>
-              <a:rPr sz="1600">
-                <a:solidFill>
-                  <a:srgbClr val="DCDCDC"/>
-                </a:solidFill>
-                <a:latin typeface="Consolas"/>
-              </a:rPr>
-              <a:t>{</a:t>
+              <a:t>u8</a:t>
+            </a:r>
+            <a:r>
+              <a:rPr sz="1600">
+                <a:solidFill>
+                  <a:srgbClr val="DCDCDC"/>
+                </a:solidFill>
+                <a:latin typeface="Consolas"/>
+              </a:rPr>
+              <a:t>::</a:t>
+            </a:r>
+            <a:r>
+              <a:rPr sz="1600">
+                <a:solidFill>
+                  <a:srgbClr val="DCDCDC"/>
+                </a:solidFill>
+                <a:latin typeface="Consolas"/>
+              </a:rPr>
+              <a:t>MAX</a:t>
             </a:r>
           </a:p>
           <a:p>
@@ -5069,34 +5105,16 @@
                 </a:solidFill>
                 <a:latin typeface="Consolas"/>
               </a:rPr>
-              <a:t>        </a:t>
-            </a:r>
-            <a:r>
-              <a:rPr sz="1600">
-                <a:solidFill>
-                  <a:srgbClr val="C586C0"/>
-                </a:solidFill>
-                <a:latin typeface="Consolas"/>
-              </a:rPr>
-              <a:t>u8</a:t>
-            </a:r>
-            <a:r>
-              <a:rPr sz="1600">
-                <a:solidFill>
-                  <a:srgbClr val="DCDCDC"/>
-                </a:solidFill>
-                <a:latin typeface="Consolas"/>
-              </a:rPr>
-              <a:t>::</a:t>
-            </a:r>
-            <a:r>
-              <a:rPr sz="1600">
-                <a:solidFill>
-                  <a:srgbClr val="DCDCDC"/>
-                </a:solidFill>
-                <a:latin typeface="Consolas"/>
-              </a:rPr>
-              <a:t>MAX</a:t>
+              <a:t>    </a:t>
+            </a:r>
+            <a:r>
+              <a:rPr sz="1600">
+                <a:solidFill>
+                  <a:srgbClr val="DCDCDC"/>
+                </a:solidFill>
+                <a:latin typeface="Consolas"/>
+              </a:rPr>
+              <a:t>}</a:t>
             </a:r>
           </a:p>
           <a:p>
@@ -5111,15 +5129,6 @@
                 <a:spcPts val="0"/>
               </a:spcAft>
             </a:pPr>
-            <a:r>
-              <a:rPr sz="1600">
-                <a:solidFill>
-                  <a:srgbClr val="DCDCDC"/>
-                </a:solidFill>
-                <a:latin typeface="Consolas"/>
-              </a:rPr>
-              <a:t>    </a:t>
-            </a:r>
             <a:r>
               <a:rPr sz="1600">
                 <a:solidFill>
@@ -5226,15 +5235,6 @@
                 <a:spcPts val="0"/>
               </a:spcAft>
             </a:pPr>
-            <a:r>
-              <a:rPr sz="1600">
-                <a:solidFill>
-                  <a:srgbClr val="DCDCDC"/>
-                </a:solidFill>
-                <a:latin typeface="Consolas"/>
-              </a:rPr>
-              <a:t>}</a:t>
-            </a:r>
           </a:p>
           <a:p>
             <a:pPr>
@@ -5248,6 +5248,87 @@
                 <a:spcPts val="0"/>
               </a:spcAft>
             </a:pPr>
+            <a:r>
+              <a:rPr sz="1600">
+                <a:solidFill>
+                  <a:srgbClr val="C586C0"/>
+                </a:solidFill>
+                <a:latin typeface="Consolas"/>
+              </a:rPr>
+              <a:t>impl</a:t>
+            </a:r>
+            <a:r>
+              <a:rPr sz="1600">
+                <a:solidFill>
+                  <a:srgbClr val="DCDCDC"/>
+                </a:solidFill>
+                <a:latin typeface="Consolas"/>
+              </a:rPr>
+              <a:t> </a:t>
+            </a:r>
+            <a:r>
+              <a:rPr sz="1600">
+                <a:solidFill>
+                  <a:srgbClr val="DCDCDC"/>
+                </a:solidFill>
+                <a:latin typeface="Consolas"/>
+              </a:rPr>
+              <a:t>Integer</a:t>
+            </a:r>
+            <a:r>
+              <a:rPr sz="1600">
+                <a:solidFill>
+                  <a:srgbClr val="DCDCDC"/>
+                </a:solidFill>
+                <a:latin typeface="Consolas"/>
+              </a:rPr>
+              <a:t> </a:t>
+            </a:r>
+            <a:r>
+              <a:rPr sz="1600">
+                <a:solidFill>
+                  <a:srgbClr val="C586C0"/>
+                </a:solidFill>
+                <a:latin typeface="Consolas"/>
+              </a:rPr>
+              <a:t>for</a:t>
+            </a:r>
+            <a:r>
+              <a:rPr sz="1600">
+                <a:solidFill>
+                  <a:srgbClr val="DCDCDC"/>
+                </a:solidFill>
+                <a:latin typeface="Consolas"/>
+              </a:rPr>
+              <a:t> </a:t>
+            </a:r>
+            <a:r>
+              <a:rPr sz="1600">
+                <a:solidFill>
+                  <a:srgbClr val="C586C0"/>
+                </a:solidFill>
+                <a:latin typeface="Consolas"/>
+              </a:rPr>
+              <a:t>i16</a:t>
+            </a:r>
+            <a:r>
+              <a:rPr sz="1600">
+                <a:solidFill>
+                  <a:srgbClr val="DCDCDC"/>
+                </a:solidFill>
+                <a:latin typeface="Consolas"/>
+              </a:rPr>
+              <a:t> </a:t>
+            </a:r>
+            <a:r>
+              <a:rPr sz="1600">
+                <a:solidFill>
+                  <a:srgbClr val="DCDCDC"/>
+                </a:solidFill>
+                <a:latin typeface="Consolas"/>
+              </a:rPr>
+              <a:t>{</a:t>
+            </a:r>
           </a:p>
           <a:p>
             <a:pPr>
@@ -5264,11 +5345,20 @@
             <a:r>
               <a:rPr sz="1600">
                 <a:solidFill>
+                  <a:srgbClr val="DCDCDC"/>
+                </a:solidFill>
+                <a:latin typeface="Consolas"/>
+              </a:rPr>
+              <a:t>    </a:t>
+            </a:r>
+            <a:r>
+              <a:rPr sz="1600">
+                <a:solidFill>
                   <a:srgbClr val="C586C0"/>
                 </a:solidFill>
                 <a:latin typeface="Consolas"/>
               </a:rPr>
-              <a:t>impl</a:t>
+              <a:t>fn</a:t>
             </a:r>
             <a:r>
               <a:rPr sz="1600">
@@ -5282,11 +5372,29 @@
             <a:r>
               <a:rPr sz="1600">
                 <a:solidFill>
-                  <a:srgbClr val="DCDCDC"/>
-                </a:solidFill>
-                <a:latin typeface="Consolas"/>
-              </a:rPr>
-              <a:t>Integer</a:t>
+                  <a:srgbClr val="DCDCAA"/>
+                </a:solidFill>
+                <a:latin typeface="Consolas"/>
+              </a:rPr>
+              <a:t>min_value</a:t>
+            </a:r>
+            <a:r>
+              <a:rPr sz="1600">
+                <a:solidFill>
+                  <a:srgbClr val="DCDCDC"/>
+                </a:solidFill>
+                <a:latin typeface="Consolas"/>
+              </a:rPr>
+              <a:t>(</a:t>
+            </a:r>
+            <a:r>
+              <a:rPr sz="1600">
+                <a:solidFill>
+                  <a:srgbClr val="DCDCDC"/>
+                </a:solidFill>
+                <a:latin typeface="Consolas"/>
+              </a:rPr>
+              <a:t>)</a:t>
             </a:r>
             <a:r>
               <a:rPr sz="1600">
@@ -5300,11 +5408,11 @@
             <a:r>
               <a:rPr sz="1600">
                 <a:solidFill>
-                  <a:srgbClr val="C586C0"/>
-                </a:solidFill>
-                <a:latin typeface="Consolas"/>
-              </a:rPr>
-              <a:t>for</a:t>
+                  <a:srgbClr val="DCDCDC"/>
+                </a:solidFill>
+                <a:latin typeface="Consolas"/>
+              </a:rPr>
+              <a:t>-&gt;</a:t>
             </a:r>
             <a:r>
               <a:rPr sz="1600">
@@ -5318,11 +5426,11 @@
             <a:r>
               <a:rPr sz="1600">
                 <a:solidFill>
-                  <a:srgbClr val="C586C0"/>
-                </a:solidFill>
-                <a:latin typeface="Consolas"/>
-              </a:rPr>
-              <a:t>i16</a:t>
+                  <a:srgbClr val="4EC9B0"/>
+                </a:solidFill>
+                <a:latin typeface="Consolas"/>
+              </a:rPr>
+              <a:t>Self</a:t>
             </a:r>
             <a:r>
               <a:rPr sz="1600">
@@ -5362,7 +5470,7 @@
                 </a:solidFill>
                 <a:latin typeface="Consolas"/>
               </a:rPr>
-              <a:t>    </a:t>
+              <a:t>        </a:t>
             </a:r>
             <a:r>
               <a:rPr sz="1600">
@@ -5371,97 +5479,25 @@
                 </a:solidFill>
                 <a:latin typeface="Consolas"/>
               </a:rPr>
-              <a:t>fn</a:t>
-            </a:r>
-            <a:r>
-              <a:rPr sz="1600">
-                <a:solidFill>
-                  <a:srgbClr val="DCDCDC"/>
-                </a:solidFill>
-                <a:latin typeface="Consolas"/>
-              </a:rPr>
-              <a:t> </a:t>
-            </a:r>
-            <a:r>
-              <a:rPr sz="1600">
-                <a:solidFill>
-                  <a:srgbClr val="DCDCAA"/>
-                </a:solidFill>
-                <a:latin typeface="Consolas"/>
-              </a:rPr>
-              <a:t>min_value</a:t>
-            </a:r>
-            <a:r>
-              <a:rPr sz="1600">
-                <a:solidFill>
-                  <a:srgbClr val="DCDCDC"/>
-                </a:solidFill>
-                <a:latin typeface="Consolas"/>
-              </a:rPr>
-              <a:t>(</a:t>
-            </a:r>
-            <a:r>
-              <a:rPr sz="1600">
-                <a:solidFill>
-                  <a:srgbClr val="DCDCDC"/>
-                </a:solidFill>
-                <a:latin typeface="Consolas"/>
-              </a:rPr>
-              <a:t>)</a:t>
-            </a:r>
-            <a:r>
-              <a:rPr sz="1600">
-                <a:solidFill>
-                  <a:srgbClr val="DCDCDC"/>
-                </a:solidFill>
-                <a:latin typeface="Consolas"/>
-              </a:rPr>
-              <a:t> </a:t>
-            </a:r>
-            <a:r>
-              <a:rPr sz="1600">
-                <a:solidFill>
-                  <a:srgbClr val="DCDCDC"/>
-                </a:solidFill>
-                <a:latin typeface="Consolas"/>
-              </a:rPr>
-              <a:t>-&gt;</a:t>
-            </a:r>
-            <a:r>
-              <a:rPr sz="1600">
-                <a:solidFill>
-                  <a:srgbClr val="DCDCDC"/>
-                </a:solidFill>
-                <a:latin typeface="Consolas"/>
-              </a:rPr>
-              <a:t> </a:t>
-            </a:r>
-            <a:r>
-              <a:rPr sz="1600">
-                <a:solidFill>
-                  <a:srgbClr val="4EC9B0"/>
-                </a:solidFill>
-                <a:latin typeface="Consolas"/>
-              </a:rPr>
-              <a:t>Self</a:t>
-            </a:r>
-            <a:r>
-              <a:rPr sz="1600">
-                <a:solidFill>
-                  <a:srgbClr val="DCDCDC"/>
-                </a:solidFill>
-                <a:latin typeface="Consolas"/>
-              </a:rPr>
-              <a:t> </a:t>
-            </a:r>
-            <a:r>
-              <a:rPr sz="1600">
-                <a:solidFill>
-                  <a:srgbClr val="DCDCDC"/>
-                </a:solidFill>
-                <a:latin typeface="Consolas"/>
-              </a:rPr>
-              <a:t>{</a:t>
+              <a:t>i16</a:t>
+            </a:r>
+            <a:r>
+              <a:rPr sz="1600">
+                <a:solidFill>
+                  <a:srgbClr val="DCDCDC"/>
+                </a:solidFill>
+                <a:latin typeface="Consolas"/>
+              </a:rPr>
+              <a:t>::</a:t>
+            </a:r>
+            <a:r>
+              <a:rPr sz="1600">
+                <a:solidFill>
+                  <a:srgbClr val="DCDCDC"/>
+                </a:solidFill>
+                <a:latin typeface="Consolas"/>
+              </a:rPr>
+              <a:t>MIN</a:t>
             </a:r>
           </a:p>
           <a:p>
@@ -5483,34 +5519,16 @@
                 </a:solidFill>
                 <a:latin typeface="Consolas"/>
               </a:rPr>
-              <a:t>        </a:t>
-            </a:r>
-            <a:r>
-              <a:rPr sz="1600">
-                <a:solidFill>
-                  <a:srgbClr val="C586C0"/>
-                </a:solidFill>
-                <a:latin typeface="Consolas"/>
-              </a:rPr>
-              <a:t>i16</a:t>
-            </a:r>
-            <a:r>
-              <a:rPr sz="1600">
-                <a:solidFill>
-                  <a:srgbClr val="DCDCDC"/>
-                </a:solidFill>
-                <a:latin typeface="Consolas"/>
-              </a:rPr>
-              <a:t>::</a:t>
-            </a:r>
-            <a:r>
-              <a:rPr sz="1600">
-                <a:solidFill>
-                  <a:srgbClr val="DCDCDC"/>
-                </a:solidFill>
-                <a:latin typeface="Consolas"/>
-              </a:rPr>
-              <a:t>MIN</a:t>
+              <a:t>    </a:t>
+            </a:r>
+            <a:r>
+              <a:rPr sz="1600">
+                <a:solidFill>
+                  <a:srgbClr val="DCDCDC"/>
+                </a:solidFill>
+                <a:latin typeface="Consolas"/>
+              </a:rPr>
+              <a:t>}</a:t>
             </a:r>
           </a:p>
           <a:p>
@@ -5525,24 +5543,6 @@
                 <a:spcPts val="0"/>
               </a:spcAft>
             </a:pPr>
-            <a:r>
-              <a:rPr sz="1600">
-                <a:solidFill>
-                  <a:srgbClr val="DCDCDC"/>
-                </a:solidFill>
-                <a:latin typeface="Consolas"/>
-              </a:rPr>
-              <a:t>    </a:t>
-            </a:r>
-            <a:r>
-              <a:rPr sz="1600">
-                <a:solidFill>
-                  <a:srgbClr val="DCDCDC"/>
-                </a:solidFill>
-                <a:latin typeface="Consolas"/>
-              </a:rPr>
-              <a:t>}</a:t>
-            </a:r>
           </a:p>
           <a:p>
             <a:pPr>
@@ -5556,6 +5556,114 @@
                 <a:spcPts val="0"/>
               </a:spcAft>
             </a:pPr>
+            <a:r>
+              <a:rPr sz="1600">
+                <a:solidFill>
+                  <a:srgbClr val="DCDCDC"/>
+                </a:solidFill>
+                <a:latin typeface="Consolas"/>
+              </a:rPr>
+              <a:t>    </a:t>
+            </a:r>
+            <a:r>
+              <a:rPr sz="1600">
+                <a:solidFill>
+                  <a:srgbClr val="C586C0"/>
+                </a:solidFill>
+                <a:latin typeface="Consolas"/>
+              </a:rPr>
+              <a:t>fn</a:t>
+            </a:r>
+            <a:r>
+              <a:rPr sz="1600">
+                <a:solidFill>
+                  <a:srgbClr val="DCDCDC"/>
+                </a:solidFill>
+                <a:latin typeface="Consolas"/>
+              </a:rPr>
+              <a:t> </a:t>
+            </a:r>
+            <a:r>
+              <a:rPr sz="1600">
+                <a:solidFill>
+                  <a:srgbClr val="DCDCAA"/>
+                </a:solidFill>
+                <a:latin typeface="Consolas"/>
+              </a:rPr>
+              <a:t>max_value</a:t>
+            </a:r>
+            <a:r>
+              <a:rPr sz="1600">
+                <a:solidFill>
+                  <a:srgbClr val="DCDCDC"/>
+                </a:solidFill>
+                <a:latin typeface="Consolas"/>
+              </a:rPr>
+              <a:t>(</a:t>
+            </a:r>
+            <a:r>
+              <a:rPr sz="1600">
+                <a:solidFill>
+                  <a:srgbClr val="DCDCDC"/>
+                </a:solidFill>
+                <a:latin typeface="Consolas"/>
+              </a:rPr>
+              <a:t>)</a:t>
+            </a:r>
+            <a:r>
+              <a:rPr sz="1600">
+                <a:solidFill>
+                  <a:srgbClr val="DCDCDC"/>
+                </a:solidFill>
+                <a:latin typeface="Consolas"/>
+              </a:rPr>
+              <a:t> </a:t>
+            </a:r>
+            <a:r>
+              <a:rPr sz="1600">
+                <a:solidFill>
+                  <a:srgbClr val="DCDCDC"/>
+                </a:solidFill>
+                <a:latin typeface="Consolas"/>
+              </a:rPr>
+              <a:t>-&gt;</a:t>
+            </a:r>
+            <a:r>
+              <a:rPr sz="1600">
+                <a:solidFill>
+                  <a:srgbClr val="DCDCDC"/>
+                </a:solidFill>
+                <a:latin typeface="Consolas"/>
+              </a:rPr>
+              <a:t> </a:t>
+            </a:r>
+            <a:r>
+              <a:rPr sz="1600">
+                <a:solidFill>
+                  <a:srgbClr val="4EC9B0"/>
+                </a:solidFill>
+                <a:latin typeface="Consolas"/>
+              </a:rPr>
+              <a:t>Self</a:t>
+            </a:r>
+            <a:r>
+              <a:rPr sz="1600">
+                <a:solidFill>
+                  <a:srgbClr val="DCDCDC"/>
+                </a:solidFill>
+                <a:latin typeface="Consolas"/>
+              </a:rPr>
+              <a:t> </a:t>
+            </a:r>
+            <a:r>
+              <a:rPr sz="1600">
+                <a:solidFill>
+                  <a:srgbClr val="DCDCDC"/>
+                </a:solidFill>
+                <a:latin typeface="Consolas"/>
+              </a:rPr>
+              <a:t>{</a:t>
+            </a:r>
           </a:p>
           <a:p>
             <a:pPr>
@@ -5576,7 +5684,7 @@
                 </a:solidFill>
                 <a:latin typeface="Consolas"/>
               </a:rPr>
-              <a:t>    </a:t>
+              <a:t>        </a:t>
             </a:r>
             <a:r>
               <a:rPr sz="1600">
@@ -5585,97 +5693,25 @@
                 </a:solidFill>
                 <a:latin typeface="Consolas"/>
               </a:rPr>
-              <a:t>fn</a:t>
-            </a:r>
-            <a:r>
-              <a:rPr sz="1600">
-                <a:solidFill>
-                  <a:srgbClr val="DCDCDC"/>
-                </a:solidFill>
-                <a:latin typeface="Consolas"/>
-              </a:rPr>
-              <a:t> </a:t>
-            </a:r>
-            <a:r>
-              <a:rPr sz="1600">
-                <a:solidFill>
-                  <a:srgbClr val="DCDCAA"/>
-                </a:solidFill>
-                <a:latin typeface="Consolas"/>
-              </a:rPr>
-              <a:t>max_value</a:t>
-            </a:r>
-            <a:r>
-              <a:rPr sz="1600">
-                <a:solidFill>
-                  <a:srgbClr val="DCDCDC"/>
-                </a:solidFill>
-                <a:latin typeface="Consolas"/>
-              </a:rPr>
-              <a:t>(</a:t>
-            </a:r>
-            <a:r>
-              <a:rPr sz="1600">
-                <a:solidFill>
-                  <a:srgbClr val="DCDCDC"/>
-                </a:solidFill>
-                <a:latin typeface="Consolas"/>
-              </a:rPr>
-              <a:t>)</a:t>
-            </a:r>
-            <a:r>
-              <a:rPr sz="1600">
-                <a:solidFill>
-                  <a:srgbClr val="DCDCDC"/>
-                </a:solidFill>
-                <a:latin typeface="Consolas"/>
-              </a:rPr>
-              <a:t> </a:t>
-            </a:r>
-            <a:r>
-              <a:rPr sz="1600">
-                <a:solidFill>
-                  <a:srgbClr val="DCDCDC"/>
-                </a:solidFill>
-                <a:latin typeface="Consolas"/>
-              </a:rPr>
-              <a:t>-&gt;</a:t>
-            </a:r>
-            <a:r>
-              <a:rPr sz="1600">
-                <a:solidFill>
-                  <a:srgbClr val="DCDCDC"/>
-                </a:solidFill>
-                <a:latin typeface="Consolas"/>
-              </a:rPr>
-              <a:t> </a:t>
-            </a:r>
-            <a:r>
-              <a:rPr sz="1600">
-                <a:solidFill>
-                  <a:srgbClr val="4EC9B0"/>
-                </a:solidFill>
-                <a:latin typeface="Consolas"/>
-              </a:rPr>
-              <a:t>Self</a:t>
-            </a:r>
-            <a:r>
-              <a:rPr sz="1600">
-                <a:solidFill>
-                  <a:srgbClr val="DCDCDC"/>
-                </a:solidFill>
-                <a:latin typeface="Consolas"/>
-              </a:rPr>
-              <a:t> </a:t>
-            </a:r>
-            <a:r>
-              <a:rPr sz="1600">
-                <a:solidFill>
-                  <a:srgbClr val="DCDCDC"/>
-                </a:solidFill>
-                <a:latin typeface="Consolas"/>
-              </a:rPr>
-              <a:t>{</a:t>
+              <a:t>i16</a:t>
+            </a:r>
+            <a:r>
+              <a:rPr sz="1600">
+                <a:solidFill>
+                  <a:srgbClr val="DCDCDC"/>
+                </a:solidFill>
+                <a:latin typeface="Consolas"/>
+              </a:rPr>
+              <a:t>::</a:t>
+            </a:r>
+            <a:r>
+              <a:rPr sz="1600">
+                <a:solidFill>
+                  <a:srgbClr val="DCDCDC"/>
+                </a:solidFill>
+                <a:latin typeface="Consolas"/>
+              </a:rPr>
+              <a:t>MAX</a:t>
             </a:r>
           </a:p>
           <a:p>
@@ -5697,34 +5733,16 @@
                 </a:solidFill>
                 <a:latin typeface="Consolas"/>
               </a:rPr>
-              <a:t>        </a:t>
-            </a:r>
-            <a:r>
-              <a:rPr sz="1600">
-                <a:solidFill>
-                  <a:srgbClr val="C586C0"/>
-                </a:solidFill>
-                <a:latin typeface="Consolas"/>
-              </a:rPr>
-              <a:t>i16</a:t>
-            </a:r>
-            <a:r>
-              <a:rPr sz="1600">
-                <a:solidFill>
-                  <a:srgbClr val="DCDCDC"/>
-                </a:solidFill>
-                <a:latin typeface="Consolas"/>
-              </a:rPr>
-              <a:t>::</a:t>
-            </a:r>
-            <a:r>
-              <a:rPr sz="1600">
-                <a:solidFill>
-                  <a:srgbClr val="DCDCDC"/>
-                </a:solidFill>
-                <a:latin typeface="Consolas"/>
-              </a:rPr>
-              <a:t>MAX</a:t>
+              <a:t>    </a:t>
+            </a:r>
+            <a:r>
+              <a:rPr sz="1600">
+                <a:solidFill>
+                  <a:srgbClr val="DCDCDC"/>
+                </a:solidFill>
+                <a:latin typeface="Consolas"/>
+              </a:rPr>
+              <a:t>}</a:t>
             </a:r>
           </a:p>
           <a:p>
@@ -5746,15 +5764,6 @@
                 </a:solidFill>
                 <a:latin typeface="Consolas"/>
               </a:rPr>
-              <a:t>    </a:t>
-            </a:r>
-            <a:r>
-              <a:rPr sz="1600">
-                <a:solidFill>
-                  <a:srgbClr val="DCDCDC"/>
-                </a:solidFill>
-                <a:latin typeface="Consolas"/>
-              </a:rPr>
               <a:t>}</a:t>
             </a:r>
           </a:p>
@@ -5770,15 +5779,6 @@
                 <a:spcPts val="0"/>
               </a:spcAft>
             </a:pPr>
-            <a:r>
-              <a:rPr sz="1600">
-                <a:solidFill>
-                  <a:srgbClr val="DCDCDC"/>
-                </a:solidFill>
-                <a:latin typeface="Consolas"/>
-              </a:rPr>
-              <a:t>}</a:t>
-            </a:r>
           </a:p>
           <a:p>
             <a:pPr>
@@ -5792,6 +5792,69 @@
                 <a:spcPts val="0"/>
               </a:spcAft>
             </a:pPr>
+            <a:r>
+              <a:rPr sz="1600">
+                <a:solidFill>
+                  <a:srgbClr val="C586C0"/>
+                </a:solidFill>
+                <a:latin typeface="Consolas"/>
+              </a:rPr>
+              <a:t>fn</a:t>
+            </a:r>
+            <a:r>
+              <a:rPr sz="1600">
+                <a:solidFill>
+                  <a:srgbClr val="DCDCDC"/>
+                </a:solidFill>
+                <a:latin typeface="Consolas"/>
+              </a:rPr>
+              <a:t> </a:t>
+            </a:r>
+            <a:r>
+              <a:rPr sz="1600">
+                <a:solidFill>
+                  <a:srgbClr val="DCDCAA"/>
+                </a:solidFill>
+                <a:latin typeface="Consolas"/>
+              </a:rPr>
+              <a:t>main</a:t>
+            </a:r>
+            <a:r>
+              <a:rPr sz="1600">
+                <a:solidFill>
+                  <a:srgbClr val="DCDCDC"/>
+                </a:solidFill>
+                <a:latin typeface="Consolas"/>
+              </a:rPr>
+              <a:t>(</a:t>
+            </a:r>
+            <a:r>
+              <a:rPr sz="1600">
+                <a:solidFill>
+                  <a:srgbClr val="DCDCDC"/>
+                </a:solidFill>
+                <a:latin typeface="Consolas"/>
+              </a:rPr>
+              <a:t>)</a:t>
+            </a:r>
+            <a:r>
+              <a:rPr sz="1600">
+                <a:solidFill>
+                  <a:srgbClr val="DCDCDC"/>
+                </a:solidFill>
+                <a:latin typeface="Consolas"/>
+              </a:rPr>
+              <a:t> </a:t>
+            </a:r>
+            <a:r>
+              <a:rPr sz="1600">
+                <a:solidFill>
+                  <a:srgbClr val="DCDCDC"/>
+                </a:solidFill>
+                <a:latin typeface="Consolas"/>
+              </a:rPr>
+              <a:t>{</a:t>
+            </a:r>
           </a:p>
           <a:p>
             <a:pPr>
@@ -5808,11 +5871,20 @@
             <a:r>
               <a:rPr sz="1600">
                 <a:solidFill>
+                  <a:srgbClr val="DCDCDC"/>
+                </a:solidFill>
+                <a:latin typeface="Consolas"/>
+              </a:rPr>
+              <a:t>    </a:t>
+            </a:r>
+            <a:r>
+              <a:rPr sz="1600">
+                <a:solidFill>
                   <a:srgbClr val="C586C0"/>
                 </a:solidFill>
                 <a:latin typeface="Consolas"/>
               </a:rPr>
-              <a:t>fn</a:t>
+              <a:t>let</a:t>
             </a:r>
             <a:r>
               <a:rPr sz="1600">
@@ -5826,11 +5898,65 @@
             <a:r>
               <a:rPr sz="1600">
                 <a:solidFill>
-                  <a:srgbClr val="DCDCAA"/>
-                </a:solidFill>
-                <a:latin typeface="Consolas"/>
-              </a:rPr>
-              <a:t>main</a:t>
+                  <a:srgbClr val="DCDCDC"/>
+                </a:solidFill>
+                <a:latin typeface="Consolas"/>
+              </a:rPr>
+              <a:t>r1</a:t>
+            </a:r>
+            <a:r>
+              <a:rPr sz="1600">
+                <a:solidFill>
+                  <a:srgbClr val="DCDCDC"/>
+                </a:solidFill>
+                <a:latin typeface="Consolas"/>
+              </a:rPr>
+              <a:t> </a:t>
+            </a:r>
+            <a:r>
+              <a:rPr sz="1600">
+                <a:solidFill>
+                  <a:srgbClr val="DCDCDC"/>
+                </a:solidFill>
+                <a:latin typeface="Consolas"/>
+              </a:rPr>
+              <a:t>=</a:t>
+            </a:r>
+            <a:r>
+              <a:rPr sz="1600">
+                <a:solidFill>
+                  <a:srgbClr val="DCDCDC"/>
+                </a:solidFill>
+                <a:latin typeface="Consolas"/>
+              </a:rPr>
+              <a:t> </a:t>
+            </a:r>
+            <a:r>
+              <a:rPr sz="1600">
+                <a:solidFill>
+                  <a:srgbClr val="C586C0"/>
+                </a:solidFill>
+                <a:latin typeface="Consolas"/>
+              </a:rPr>
+              <a:t>u8</a:t>
+            </a:r>
+            <a:r>
+              <a:rPr sz="1600">
+                <a:solidFill>
+                  <a:srgbClr val="DCDCDC"/>
+                </a:solidFill>
+                <a:latin typeface="Consolas"/>
+              </a:rPr>
+              <a:t>::</a:t>
+            </a:r>
+            <a:r>
+              <a:rPr sz="1600">
+                <a:solidFill>
+                  <a:srgbClr val="DCDCDC"/>
+                </a:solidFill>
+                <a:latin typeface="Consolas"/>
+              </a:rPr>
+              <a:t>exhausted_range</a:t>
             </a:r>
             <a:r>
               <a:rPr sz="1600">
@@ -5857,16 +5983,7 @@
                 </a:solidFill>
                 <a:latin typeface="Consolas"/>
               </a:rPr>
-              <a:t> </a:t>
-            </a:r>
-            <a:r>
-              <a:rPr sz="1600">
-                <a:solidFill>
-                  <a:srgbClr val="DCDCDC"/>
-                </a:solidFill>
-                <a:latin typeface="Consolas"/>
-              </a:rPr>
-              <a:t>{</a:t>
+              <a:t>;</a:t>
             </a:r>
           </a:p>
           <a:p>
@@ -5915,7 +6032,7 @@
                 </a:solidFill>
                 <a:latin typeface="Consolas"/>
               </a:rPr>
-              <a:t>r1</a:t>
+              <a:t>r2</a:t>
             </a:r>
             <a:r>
               <a:rPr sz="1600">
@@ -5951,7 +6068,7 @@
                 </a:solidFill>
                 <a:latin typeface="Consolas"/>
               </a:rPr>
-              <a:t>u8</a:t>
+              <a:t>i16</a:t>
             </a:r>
             <a:r>
               <a:rPr sz="1600">
@@ -6011,123 +6128,6 @@
                 <a:spcPts val="0"/>
               </a:spcAft>
             </a:pPr>
-            <a:r>
-              <a:rPr sz="1600">
-                <a:solidFill>
-                  <a:srgbClr val="DCDCDC"/>
-                </a:solidFill>
-                <a:latin typeface="Consolas"/>
-              </a:rPr>
-              <a:t>    </a:t>
-            </a:r>
-            <a:r>
-              <a:rPr sz="1600">
-                <a:solidFill>
-                  <a:srgbClr val="C586C0"/>
-                </a:solidFill>
-                <a:latin typeface="Consolas"/>
-              </a:rPr>
-              <a:t>let</a:t>
-            </a:r>
-            <a:r>
-              <a:rPr sz="1600">
-                <a:solidFill>
-                  <a:srgbClr val="DCDCDC"/>
-                </a:solidFill>
-                <a:latin typeface="Consolas"/>
-              </a:rPr>
-              <a:t> </a:t>
-            </a:r>
-            <a:r>
-              <a:rPr sz="1600">
-                <a:solidFill>
-                  <a:srgbClr val="DCDCDC"/>
-                </a:solidFill>
-                <a:latin typeface="Consolas"/>
-              </a:rPr>
-              <a:t>r2</a:t>
-            </a:r>
-            <a:r>
-              <a:rPr sz="1600">
-                <a:solidFill>
-                  <a:srgbClr val="DCDCDC"/>
-                </a:solidFill>
-                <a:latin typeface="Consolas"/>
-              </a:rPr>
-              <a:t> </a:t>
-            </a:r>
-            <a:r>
-              <a:rPr sz="1600">
-                <a:solidFill>
-                  <a:srgbClr val="DCDCDC"/>
-                </a:solidFill>
-                <a:latin typeface="Consolas"/>
-              </a:rPr>
-              <a:t>=</a:t>
-            </a:r>
-            <a:r>
-              <a:rPr sz="1600">
-                <a:solidFill>
-                  <a:srgbClr val="DCDCDC"/>
-                </a:solidFill>
-                <a:latin typeface="Consolas"/>
-              </a:rPr>
-              <a:t> </a:t>
-            </a:r>
-            <a:r>
-              <a:rPr sz="1600">
-                <a:solidFill>
-                  <a:srgbClr val="C586C0"/>
-                </a:solidFill>
-                <a:latin typeface="Consolas"/>
-              </a:rPr>
-              <a:t>i16</a:t>
-            </a:r>
-            <a:r>
-              <a:rPr sz="1600">
-                <a:solidFill>
-                  <a:srgbClr val="DCDCDC"/>
-                </a:solidFill>
-                <a:latin typeface="Consolas"/>
-              </a:rPr>
-              <a:t>::</a:t>
-            </a:r>
-            <a:r>
-              <a:rPr sz="1600">
-                <a:solidFill>
-                  <a:srgbClr val="DCDCDC"/>
-                </a:solidFill>
-                <a:latin typeface="Consolas"/>
-              </a:rPr>
-              <a:t>exhausted_range</a:t>
-            </a:r>
-            <a:r>
-              <a:rPr sz="1600">
-                <a:solidFill>
-                  <a:srgbClr val="DCDCDC"/>
-                </a:solidFill>
-                <a:latin typeface="Consolas"/>
-              </a:rPr>
-              <a:t>(</a:t>
-            </a:r>
-            <a:r>
-              <a:rPr sz="1600">
-                <a:solidFill>
-                  <a:srgbClr val="DCDCDC"/>
-                </a:solidFill>
-                <a:latin typeface="Consolas"/>
-              </a:rPr>
-              <a:t>)</a:t>
-            </a:r>
-            <a:r>
-              <a:rPr sz="1600">
-                <a:solidFill>
-                  <a:srgbClr val="DCDCDC"/>
-                </a:solidFill>
-                <a:latin typeface="Consolas"/>
-              </a:rPr>
-              <a:t>;</a:t>
-            </a:r>
           </a:p>
           <a:p>
             <a:pPr>
@@ -6141,6 +6141,96 @@
                 <a:spcPts val="0"/>
               </a:spcAft>
             </a:pPr>
+            <a:r>
+              <a:rPr sz="1600">
+                <a:solidFill>
+                  <a:srgbClr val="DCDCDC"/>
+                </a:solidFill>
+                <a:latin typeface="Consolas"/>
+              </a:rPr>
+              <a:t>    </a:t>
+            </a:r>
+            <a:r>
+              <a:rPr sz="1600">
+                <a:solidFill>
+                  <a:srgbClr val="DCDCAA"/>
+                </a:solidFill>
+                <a:latin typeface="Consolas"/>
+              </a:rPr>
+              <a:t>assert!</a:t>
+            </a:r>
+            <a:r>
+              <a:rPr sz="1600">
+                <a:solidFill>
+                  <a:srgbClr val="DCDCDC"/>
+                </a:solidFill>
+                <a:latin typeface="Consolas"/>
+              </a:rPr>
+              <a:t>(</a:t>
+            </a:r>
+            <a:r>
+              <a:rPr sz="1600">
+                <a:solidFill>
+                  <a:srgbClr val="DCDCDC"/>
+                </a:solidFill>
+                <a:latin typeface="Consolas"/>
+              </a:rPr>
+              <a:t>r1</a:t>
+            </a:r>
+            <a:r>
+              <a:rPr sz="1600">
+                <a:solidFill>
+                  <a:srgbClr val="DCDCDC"/>
+                </a:solidFill>
+                <a:latin typeface="Consolas"/>
+              </a:rPr>
+              <a:t>.</a:t>
+            </a:r>
+            <a:r>
+              <a:rPr sz="1600">
+                <a:solidFill>
+                  <a:srgbClr val="DCDCDC"/>
+                </a:solidFill>
+                <a:latin typeface="Consolas"/>
+              </a:rPr>
+              <a:t>is_empty</a:t>
+            </a:r>
+            <a:r>
+              <a:rPr sz="1600">
+                <a:solidFill>
+                  <a:srgbClr val="DCDCDC"/>
+                </a:solidFill>
+                <a:latin typeface="Consolas"/>
+              </a:rPr>
+              <a:t>(</a:t>
+            </a:r>
+            <a:r>
+              <a:rPr sz="1600">
+                <a:solidFill>
+                  <a:srgbClr val="DCDCDC"/>
+                </a:solidFill>
+                <a:latin typeface="Consolas"/>
+              </a:rPr>
+              <a:t>)</a:t>
+            </a:r>
+            <a:r>
+              <a:rPr sz="1600">
+                <a:solidFill>
+                  <a:srgbClr val="DCDCDC"/>
+                </a:solidFill>
+                <a:latin typeface="Consolas"/>
+              </a:rPr>
+              <a:t>)</a:t>
+            </a:r>
+            <a:r>
+              <a:rPr sz="1600">
+                <a:solidFill>
+                  <a:srgbClr val="DCDCDC"/>
+                </a:solidFill>
+                <a:latin typeface="Consolas"/>
+              </a:rPr>
+              <a:t>;</a:t>
+            </a:r>
           </a:p>
           <a:p>
             <a:pPr>
@@ -6170,7 +6260,7 @@
                 </a:solidFill>
                 <a:latin typeface="Consolas"/>
               </a:rPr>
-              <a:t>println!</a:t>
+              <a:t>assert!</a:t>
             </a:r>
             <a:r>
               <a:rPr sz="1600">
@@ -6180,199 +6270,6 @@
                 <a:latin typeface="Consolas"/>
               </a:rPr>
               <a:t>(</a:t>
-            </a:r>
-            <a:r>
-              <a:rPr sz="1600">
-                <a:solidFill>
-                  <a:srgbClr val="CE9178"/>
-                </a:solidFill>
-                <a:latin typeface="Consolas"/>
-              </a:rPr>
-              <a:t>"</a:t>
-            </a:r>
-            <a:r>
-              <a:rPr sz="1600">
-                <a:solidFill>
-                  <a:srgbClr val="CE9178"/>
-                </a:solidFill>
-                <a:latin typeface="Consolas"/>
-              </a:rPr>
-              <a:t>u8 exhausted range is empty: {}</a:t>
-            </a:r>
-            <a:r>
-              <a:rPr sz="1600">
-                <a:solidFill>
-                  <a:srgbClr val="CE9178"/>
-                </a:solidFill>
-                <a:latin typeface="Consolas"/>
-              </a:rPr>
-              <a:t>"</a:t>
-            </a:r>
-            <a:r>
-              <a:rPr sz="1600">
-                <a:solidFill>
-                  <a:srgbClr val="DCDCDC"/>
-                </a:solidFill>
-                <a:latin typeface="Consolas"/>
-              </a:rPr>
-              <a:t>,</a:t>
-            </a:r>
-            <a:r>
-              <a:rPr sz="1600">
-                <a:solidFill>
-                  <a:srgbClr val="DCDCDC"/>
-                </a:solidFill>
-                <a:latin typeface="Consolas"/>
-              </a:rPr>
-              <a:t> </a:t>
-            </a:r>
-            <a:r>
-              <a:rPr sz="1600">
-                <a:solidFill>
-                  <a:srgbClr val="DCDCDC"/>
-                </a:solidFill>
-                <a:latin typeface="Consolas"/>
-              </a:rPr>
-              <a:t>r1</a:t>
-            </a:r>
-            <a:r>
-              <a:rPr sz="1600">
-                <a:solidFill>
-                  <a:srgbClr val="DCDCDC"/>
-                </a:solidFill>
-                <a:latin typeface="Consolas"/>
-              </a:rPr>
-              <a:t>.</a:t>
-            </a:r>
-            <a:r>
-              <a:rPr sz="1600">
-                <a:solidFill>
-                  <a:srgbClr val="DCDCDC"/>
-                </a:solidFill>
-                <a:latin typeface="Consolas"/>
-              </a:rPr>
-              <a:t>is_empty</a:t>
-            </a:r>
-            <a:r>
-              <a:rPr sz="1600">
-                <a:solidFill>
-                  <a:srgbClr val="DCDCDC"/>
-                </a:solidFill>
-                <a:latin typeface="Consolas"/>
-              </a:rPr>
-              <a:t>(</a:t>
-            </a:r>
-            <a:r>
-              <a:rPr sz="1600">
-                <a:solidFill>
-                  <a:srgbClr val="DCDCDC"/>
-                </a:solidFill>
-                <a:latin typeface="Consolas"/>
-              </a:rPr>
-              <a:t>)</a:t>
-            </a:r>
-            <a:r>
-              <a:rPr sz="1600">
-                <a:solidFill>
-                  <a:srgbClr val="DCDCDC"/>
-                </a:solidFill>
-                <a:latin typeface="Consolas"/>
-              </a:rPr>
-              <a:t>)</a:t>
-            </a:r>
-            <a:r>
-              <a:rPr sz="1600">
-                <a:solidFill>
-                  <a:srgbClr val="DCDCDC"/>
-                </a:solidFill>
-                <a:latin typeface="Consolas"/>
-              </a:rPr>
-              <a:t>;</a:t>
-            </a:r>
-          </a:p>
-          <a:p>
-            <a:pPr>
-              <a:lnSpc>
-                <a:spcPct val="95000"/>
-              </a:lnSpc>
-              <a:spcBef>
-                <a:spcPts val="0"/>
-              </a:spcBef>
-              <a:spcAft>
-                <a:spcPts val="0"/>
-              </a:spcAft>
-            </a:pPr>
-            <a:r>
-              <a:rPr sz="1600">
-                <a:solidFill>
-                  <a:srgbClr val="DCDCDC"/>
-                </a:solidFill>
-                <a:latin typeface="Consolas"/>
-              </a:rPr>
-              <a:t>    </a:t>
-            </a:r>
-            <a:r>
-              <a:rPr sz="1600">
-                <a:solidFill>
-                  <a:srgbClr val="DCDCAA"/>
-                </a:solidFill>
-                <a:latin typeface="Consolas"/>
-              </a:rPr>
-              <a:t>println!</a:t>
-            </a:r>
-            <a:r>
-              <a:rPr sz="1600">
-                <a:solidFill>
-                  <a:srgbClr val="DCDCDC"/>
-                </a:solidFill>
-                <a:latin typeface="Consolas"/>
-              </a:rPr>
-              <a:t>(</a:t>
-            </a:r>
-            <a:r>
-              <a:rPr sz="1600">
-                <a:solidFill>
-                  <a:srgbClr val="CE9178"/>
-                </a:solidFill>
-                <a:latin typeface="Consolas"/>
-              </a:rPr>
-              <a:t>"</a:t>
-            </a:r>
-            <a:r>
-              <a:rPr sz="1600">
-                <a:solidFill>
-                  <a:srgbClr val="CE9178"/>
-                </a:solidFill>
-                <a:latin typeface="Consolas"/>
-              </a:rPr>
-              <a:t>i16 exhausted range is empty: {}</a:t>
-            </a:r>
-            <a:r>
-              <a:rPr sz="1600">
-                <a:solidFill>
-                  <a:srgbClr val="CE9178"/>
-                </a:solidFill>
-                <a:latin typeface="Consolas"/>
-              </a:rPr>
-              <a:t>"</a:t>
-            </a:r>
-            <a:r>
-              <a:rPr sz="1600">
-                <a:solidFill>
-                  <a:srgbClr val="DCDCDC"/>
-                </a:solidFill>
-                <a:latin typeface="Consolas"/>
-              </a:rPr>
-              <a:t>,</a:t>
-            </a:r>
-            <a:r>
-              <a:rPr sz="1600">
-                <a:solidFill>
-                  <a:srgbClr val="DCDCDC"/>
-                </a:solidFill>
-                <a:latin typeface="Consolas"/>
-              </a:rPr>
-              <a:t> </a:t>
             </a:r>
             <a:r>
               <a:rPr sz="1600">

</xml_diff>

<commit_message>
Add example2 walkthrough presentation file
</commit_message>
<xml_diff>
--- a/docs/example1_walkthrough.pptx
+++ b/docs/example1_walkthrough.pptx
@@ -3320,52 +3320,9 @@
           </a:p>
         </p:txBody>
       </p:sp>
-      <p:sp>
-        <p:nvSpPr>
-          <p:cNvPr id="6" name="Rectangle 5"/>
-          <p:cNvSpPr/>
-          <p:nvPr/>
-        </p:nvSpPr>
-        <p:spPr>
-          <a:xfrm>
-            <a:off x="1369304" y="1618488"/>
-            <a:ext cx="5170951" cy="4992624"/>
-          </a:xfrm>
-          <a:prstGeom prst="rect">
-            <a:avLst/>
-          </a:prstGeom>
-          <a:solidFill>
-            <a:srgbClr val="0B0F14"/>
-          </a:solidFill>
-          <a:ln>
-            <a:noFill/>
-          </a:ln>
-        </p:spPr>
-        <p:style>
-          <a:lnRef idx="1">
-            <a:schemeClr val="accent1"/>
-          </a:lnRef>
-          <a:fillRef idx="3">
-            <a:schemeClr val="accent1"/>
-          </a:fillRef>
-          <a:effectRef idx="2">
-            <a:schemeClr val="accent1"/>
-          </a:effectRef>
-          <a:fontRef idx="minor">
-            <a:schemeClr val="lt1"/>
-          </a:fontRef>
-        </p:style>
-        <p:txBody>
-          <a:bodyPr rtlCol="0" anchor="ctr"/>
-          <a:lstStyle/>
-          <a:p>
-            <a:pPr algn="ctr"/>
-          </a:p>
-        </p:txBody>
-      </p:sp>
       <p:pic>
         <p:nvPicPr>
-          <p:cNvPr id="7" name="Picture 6" descr="1_puzzle_diagram.png"/>
+          <p:cNvPr id="6" name="Picture 5" descr="1_puzzle_diagram.png"/>
           <p:cNvPicPr>
             <a:picLocks noChangeAspect="1"/>
           </p:cNvPicPr>

</xml_diff>

<commit_message>
update to 16:9 size
</commit_message>
<xml_diff>
--- a/docs/example1_walkthrough.pptx
+++ b/docs/example1_walkthrough.pptx
@@ -9,7 +9,7 @@
     <p:sldId id="257" r:id="rId8"/>
     <p:sldId id="258" r:id="rId9"/>
   </p:sldIdLst>
-  <p:sldSz cx="9144000" cy="6858000" type="screen4x3"/>
+  <p:sldSz cx="12192000" cy="6858000" type="screen4x3"/>
   <p:notesSz cx="6858000" cy="9144000"/>
   <p:defaultTextStyle>
     <a:defPPr>
@@ -3099,7 +3099,7 @@
         <p:spPr>
           <a:xfrm>
             <a:off x="0" y="0"/>
-            <a:ext cx="9144000" cy="6858000"/>
+            <a:ext cx="12192000" cy="6858000"/>
           </a:xfrm>
           <a:prstGeom prst="rect">
             <a:avLst/>
@@ -3141,7 +3141,7 @@
         </p:nvSpPr>
         <p:spPr>
           <a:xfrm>
-            <a:off x="7543800" y="0"/>
+            <a:off x="10591800" y="0"/>
             <a:ext cx="1600200" cy="6858000"/>
           </a:xfrm>
           <a:prstGeom prst="rect">
@@ -3186,7 +3186,7 @@
         </p:nvSpPr>
         <p:spPr>
           <a:xfrm rot="16200000">
-            <a:off x="7616952" y="274320"/>
+            <a:off x="10664952" y="274320"/>
             <a:ext cx="1453896" cy="6309360"/>
           </a:xfrm>
           <a:prstGeom prst="rect">
@@ -3223,7 +3223,7 @@
         <p:spPr>
           <a:xfrm>
             <a:off x="731520" y="502920"/>
-            <a:ext cx="6446520" cy="1051560"/>
+            <a:ext cx="9494520" cy="1051560"/>
           </a:xfrm>
           <a:prstGeom prst="rect">
             <a:avLst/>
@@ -3336,7 +3336,7 @@
         </p:blipFill>
         <p:spPr>
           <a:xfrm>
-            <a:off x="1259576" y="1691640"/>
+            <a:off x="2783576" y="1691640"/>
             <a:ext cx="5024647" cy="4846320"/>
           </a:xfrm>
           <a:prstGeom prst="rect">
@@ -3371,7 +3371,7 @@
         <p:spPr>
           <a:xfrm>
             <a:off x="0" y="0"/>
-            <a:ext cx="9144000" cy="6858000"/>
+            <a:ext cx="12192000" cy="6858000"/>
           </a:xfrm>
           <a:prstGeom prst="rect">
             <a:avLst/>
@@ -3414,7 +3414,7 @@
         <p:spPr>
           <a:xfrm>
             <a:off x="164592" y="109728"/>
-            <a:ext cx="8814816" cy="6638544"/>
+            <a:ext cx="11862816" cy="6638544"/>
           </a:xfrm>
           <a:prstGeom prst="rect">
             <a:avLst/>
@@ -5125,7 +5125,7 @@
         <p:spPr>
           <a:xfrm>
             <a:off x="0" y="0"/>
-            <a:ext cx="9144000" cy="6858000"/>
+            <a:ext cx="12192000" cy="6858000"/>
           </a:xfrm>
           <a:prstGeom prst="rect">
             <a:avLst/>
@@ -5168,7 +5168,7 @@
         <p:spPr>
           <a:xfrm>
             <a:off x="164592" y="109728"/>
-            <a:ext cx="8814816" cy="6638544"/>
+            <a:ext cx="11862816" cy="6638544"/>
           </a:xfrm>
           <a:prstGeom prst="rect">
             <a:avLst/>

</xml_diff>